<commit_message>
Add team and division-of-work slide after the cover; update speech script
Co-Authored-By: Claude Opus 5.5 <noreply@anthropic.com>
Claude-Session: https://claude.ai/code/session_01KJ328BptsMhS4rYwT6tCdN
</commit_message>
<xml_diff>
--- a/part1/Part1_Douyin_Social_Ecommerce.pptx
+++ b/part1/Part1_Douyin_Social_Ecommerce.pptx
@@ -6,6 +6,7 @@
   </p:sldMasterIdLst>
   <p:sldIdLst>
     <p:sldId id="289" r:id="rId3"/>
+    <p:sldId id="306" r:id="rId44"/>
     <p:sldId id="290" r:id="rId4"/>
     <p:sldId id="295" r:id="rId9"/>
     <p:sldId id="305" r:id="rId19"/>
@@ -2011,6 +2012,1667 @@
           <a:chExt cx="0" cy="0"/>
         </a:xfrm>
       </p:grpSpPr>
+      <p:sp>
+        <p:nvSpPr>
+          <p:cNvPr id="69" name="object 69"/>
+          <p:cNvSpPr txBox="1">
+            <a:spLocks noGrp="1"/>
+          </p:cNvSpPr>
+          <p:nvPr>
+            <p:ph type="ftr" sz="quarter" idx="5"/>
+          </p:nvPr>
+        </p:nvSpPr>
+        <p:spPr>
+          <a:xfrm>
+            <a:off x="296567" y="6473952"/>
+            <a:ext cx="3840480" cy="274320"/>
+          </a:xfrm>
+          <a:prstGeom prst="rect">
+            <a:avLst/>
+          </a:prstGeom>
+        </p:spPr>
+        <p:txBody>
+          <a:bodyPr vert="horz" wrap="none" lIns="0" tIns="12700" rIns="0" bIns="0" rtlCol="0">
+            <a:spAutoFit/>
+          </a:bodyPr>
+          <a:lstStyle/>
+          <a:p>
+            <a:pPr marL="12700">
+              <a:lnSpc>
+                <a:spcPct val="100000"/>
+              </a:lnSpc>
+              <a:spcBef>
+                <a:spcPts val="75"/>
+              </a:spcBef>
+            </a:pPr>
+            <a:r>
+              <a:rPr sz="900" dirty="0">
+                <a:solidFill>
+                  <a:srgbClr val="FFFFFF"/>
+                </a:solidFill>
+              </a:rPr>
+              <a:t>New Media Marketing | Group Presentation</a:t>
+            </a:r>
+            <a:endParaRPr sz="1245" spc="-10" dirty="0">
+              <a:solidFill>
+                <a:srgbClr val="FFFFFF"/>
+              </a:solidFill>
+            </a:endParaRPr>
+          </a:p>
+        </p:txBody>
+      </p:sp>
+      <p:sp>
+        <p:nvSpPr>
+          <p:cNvPr id="70" name="object 70"/>
+          <p:cNvSpPr txBox="1">
+            <a:spLocks noGrp="1"/>
+          </p:cNvSpPr>
+          <p:nvPr>
+            <p:ph type="sldNum" sz="quarter" idx="7"/>
+          </p:nvPr>
+        </p:nvSpPr>
+        <p:spPr>
+          <a:xfrm>
+            <a:off x="11731863" y="6443884"/>
+            <a:ext cx="241300" cy="177165"/>
+          </a:xfrm>
+          <a:prstGeom prst="rect">
+            <a:avLst/>
+          </a:prstGeom>
+        </p:spPr>
+        <p:txBody>
+          <a:bodyPr vert="horz" wrap="square" lIns="0" tIns="13546" rIns="0" bIns="0" rtlCol="0">
+            <a:spAutoFit/>
+          </a:bodyPr>
+          <a:lstStyle/>
+          <a:p>
+            <a:pPr marL="40005">
+              <a:lnSpc>
+                <a:spcPct val="100000"/>
+              </a:lnSpc>
+              <a:spcBef>
+                <a:spcPts val="80"/>
+              </a:spcBef>
+            </a:pPr>
+            <a:fld id="{81D60167-4931-47E6-BA6A-407CBD079E47}" type="slidenum">
+              <a:rPr sz="1065" spc="-50" dirty="0"/>
+            </a:fld>
+            <a:endParaRPr sz="1065" spc="-50" dirty="0"/>
+          </a:p>
+        </p:txBody>
+      </p:sp>
+      <p:sp>
+        <p:nvSpPr>
+          <p:cNvPr id="71" name="TextBox 70"/>
+          <p:cNvSpPr txBox="1"/>
+          <p:nvPr/>
+        </p:nvSpPr>
+        <p:spPr>
+          <a:xfrm>
+            <a:off x="502920" y="347472"/>
+            <a:ext cx="11155680" cy="640080"/>
+          </a:xfrm>
+          <a:prstGeom prst="rect">
+            <a:avLst/>
+          </a:prstGeom>
+          <a:noFill/>
+        </p:spPr>
+        <p:txBody>
+          <a:bodyPr wrap="square" lIns="0" rIns="0" tIns="0" bIns="0" anchor="t">
+            <a:spAutoFit/>
+          </a:bodyPr>
+          <a:lstStyle/>
+          <a:p>
+            <a:pPr algn="l"/>
+            <a:r>
+              <a:rPr sz="3200" b="1" i="0">
+                <a:solidFill>
+                  <a:srgbClr val="FFFFFF"/>
+                </a:solidFill>
+                <a:latin typeface="Arial"/>
+                <a:ea typeface="Microsoft YaHei"/>
+                <a:cs typeface="Arial"/>
+              </a:rPr>
+              <a:t>Meet the Team: Who Covers What</a:t>
+            </a:r>
+          </a:p>
+        </p:txBody>
+      </p:sp>
+      <p:sp>
+        <p:nvSpPr>
+          <p:cNvPr id="72" name="TextBox 71"/>
+          <p:cNvSpPr txBox="1"/>
+          <p:nvPr/>
+        </p:nvSpPr>
+        <p:spPr>
+          <a:xfrm>
+            <a:off x="502920" y="987552"/>
+            <a:ext cx="11155680" cy="365760"/>
+          </a:xfrm>
+          <a:prstGeom prst="rect">
+            <a:avLst/>
+          </a:prstGeom>
+          <a:noFill/>
+        </p:spPr>
+        <p:txBody>
+          <a:bodyPr wrap="square" lIns="0" rIns="0" tIns="0" bIns="0" anchor="t">
+            <a:spAutoFit/>
+          </a:bodyPr>
+          <a:lstStyle/>
+          <a:p>
+            <a:pPr algn="l"/>
+            <a:r>
+              <a:rPr sz="1300" b="0" i="0">
+                <a:solidFill>
+                  <a:srgbClr val="C9C9C9"/>
+                </a:solidFill>
+                <a:latin typeface="Arial"/>
+                <a:ea typeface="Microsoft YaHei"/>
+                <a:cs typeface="Arial"/>
+              </a:rPr>
+              <a:t>Four presenters, four questions: what, why, how, and where next</a:t>
+            </a:r>
+          </a:p>
+        </p:txBody>
+      </p:sp>
+      <p:sp>
+        <p:nvSpPr>
+          <p:cNvPr id="73" name="Rounded Rectangle 72"/>
+          <p:cNvSpPr/>
+          <p:nvPr/>
+        </p:nvSpPr>
+        <p:spPr>
+          <a:xfrm>
+            <a:off x="502920" y="1691640"/>
+            <a:ext cx="2651760" cy="4343400"/>
+          </a:xfrm>
+          <a:prstGeom prst="roundRect">
+            <a:avLst>
+              <a:gd name="adj" fmla="val 8000"/>
+            </a:avLst>
+          </a:prstGeom>
+          <a:solidFill>
+            <a:srgbClr val="0B1F1F"/>
+          </a:solidFill>
+          <a:ln w="28575">
+            <a:solidFill>
+              <a:srgbClr val="25F4EE"/>
+            </a:solidFill>
+          </a:ln>
+          <a:effectLst/>
+        </p:spPr>
+        <p:style>
+          <a:lnRef idx="1">
+            <a:schemeClr val="accent1"/>
+          </a:lnRef>
+          <a:fillRef idx="3">
+            <a:schemeClr val="accent1"/>
+          </a:fillRef>
+          <a:effectRef idx="2">
+            <a:schemeClr val="accent1"/>
+          </a:effectRef>
+          <a:fontRef idx="minor">
+            <a:schemeClr val="lt1"/>
+          </a:fontRef>
+        </p:style>
+        <p:txBody>
+          <a:bodyPr rtlCol="0" anchor="ctr"/>
+          <a:lstStyle/>
+          <a:p/>
+        </p:txBody>
+      </p:sp>
+      <p:sp>
+        <p:nvSpPr>
+          <p:cNvPr id="74" name="Oval 73"/>
+          <p:cNvSpPr/>
+          <p:nvPr/>
+        </p:nvSpPr>
+        <p:spPr>
+          <a:xfrm>
+            <a:off x="758952" y="1965960"/>
+            <a:ext cx="685800" cy="685800"/>
+          </a:xfrm>
+          <a:prstGeom prst="ellipse">
+            <a:avLst/>
+          </a:prstGeom>
+          <a:solidFill>
+            <a:srgbClr val="25F4EE"/>
+          </a:solidFill>
+          <a:ln>
+            <a:noFill/>
+          </a:ln>
+          <a:effectLst/>
+        </p:spPr>
+        <p:style>
+          <a:lnRef idx="1">
+            <a:schemeClr val="accent1"/>
+          </a:lnRef>
+          <a:fillRef idx="3">
+            <a:schemeClr val="accent1"/>
+          </a:fillRef>
+          <a:effectRef idx="2">
+            <a:schemeClr val="accent1"/>
+          </a:effectRef>
+          <a:fontRef idx="minor">
+            <a:schemeClr val="lt1"/>
+          </a:fontRef>
+        </p:style>
+        <p:txBody>
+          <a:bodyPr rtlCol="0" anchor="ctr" lIns="0" rIns="0" tIns="0" bIns="0"/>
+          <a:lstStyle/>
+          <a:p>
+            <a:pPr algn="ctr"/>
+            <a:r>
+              <a:rPr sz="2400" b="1" i="0">
+                <a:solidFill>
+                  <a:srgbClr val="000000"/>
+                </a:solidFill>
+                <a:latin typeface="Arial"/>
+                <a:ea typeface="Microsoft YaHei"/>
+                <a:cs typeface="Arial"/>
+              </a:rPr>
+              <a:t>A</a:t>
+            </a:r>
+          </a:p>
+        </p:txBody>
+      </p:sp>
+      <p:sp>
+        <p:nvSpPr>
+          <p:cNvPr id="75" name="Rounded Rectangle 74"/>
+          <p:cNvSpPr/>
+          <p:nvPr/>
+        </p:nvSpPr>
+        <p:spPr>
+          <a:xfrm>
+            <a:off x="1645920" y="2157984"/>
+            <a:ext cx="1298448" cy="274320"/>
+          </a:xfrm>
+          <a:prstGeom prst="roundRect">
+            <a:avLst>
+              <a:gd name="adj" fmla="val 50000"/>
+            </a:avLst>
+          </a:prstGeom>
+          <a:solidFill>
+            <a:srgbClr val="25F4EE"/>
+          </a:solidFill>
+          <a:ln>
+            <a:noFill/>
+          </a:ln>
+          <a:effectLst/>
+        </p:spPr>
+        <p:style>
+          <a:lnRef idx="1">
+            <a:schemeClr val="accent1"/>
+          </a:lnRef>
+          <a:fillRef idx="3">
+            <a:schemeClr val="accent1"/>
+          </a:fillRef>
+          <a:effectRef idx="2">
+            <a:schemeClr val="accent1"/>
+          </a:effectRef>
+          <a:fontRef idx="minor">
+            <a:schemeClr val="lt1"/>
+          </a:fontRef>
+        </p:style>
+        <p:txBody>
+          <a:bodyPr rtlCol="0" anchor="ctr" lIns="73152" rIns="73152" tIns="0" bIns="0" wrap="none"/>
+          <a:lstStyle/>
+          <a:p>
+            <a:pPr algn="ctr"/>
+            <a:r>
+              <a:rPr sz="850" b="1" i="0">
+                <a:solidFill>
+                  <a:srgbClr val="000000"/>
+                </a:solidFill>
+                <a:latin typeface="Arial"/>
+                <a:ea typeface="Microsoft YaHei"/>
+                <a:cs typeface="Arial"/>
+              </a:rPr>
+              <a:t>PRESENTING NOW</a:t>
+            </a:r>
+          </a:p>
+        </p:txBody>
+      </p:sp>
+      <p:sp>
+        <p:nvSpPr>
+          <p:cNvPr id="76" name="TextBox 75"/>
+          <p:cNvSpPr txBox="1"/>
+          <p:nvPr/>
+        </p:nvSpPr>
+        <p:spPr>
+          <a:xfrm>
+            <a:off x="758952" y="2834640"/>
+            <a:ext cx="2194560" cy="320040"/>
+          </a:xfrm>
+          <a:prstGeom prst="rect">
+            <a:avLst/>
+          </a:prstGeom>
+          <a:noFill/>
+        </p:spPr>
+        <p:txBody>
+          <a:bodyPr wrap="square" lIns="0" rIns="0" tIns="0" bIns="0" anchor="t">
+            <a:spAutoFit/>
+          </a:bodyPr>
+          <a:lstStyle/>
+          <a:p>
+            <a:pPr algn="l"/>
+            <a:r>
+              <a:rPr sz="1500" b="1" i="0">
+                <a:solidFill>
+                  <a:srgbClr val="FFFFFF"/>
+                </a:solidFill>
+                <a:latin typeface="Arial"/>
+                <a:ea typeface="Microsoft YaHei"/>
+                <a:cs typeface="Arial"/>
+              </a:rPr>
+              <a:t>[Your Name]</a:t>
+            </a:r>
+          </a:p>
+        </p:txBody>
+      </p:sp>
+      <p:sp>
+        <p:nvSpPr>
+          <p:cNvPr id="77" name="TextBox 76"/>
+          <p:cNvSpPr txBox="1"/>
+          <p:nvPr/>
+        </p:nvSpPr>
+        <p:spPr>
+          <a:xfrm>
+            <a:off x="758952" y="3200400"/>
+            <a:ext cx="2194560" cy="274320"/>
+          </a:xfrm>
+          <a:prstGeom prst="rect">
+            <a:avLst/>
+          </a:prstGeom>
+          <a:noFill/>
+        </p:spPr>
+        <p:txBody>
+          <a:bodyPr wrap="square" lIns="0" rIns="0" tIns="0" bIns="0" anchor="t">
+            <a:spAutoFit/>
+          </a:bodyPr>
+          <a:lstStyle/>
+          <a:p>
+            <a:pPr algn="l"/>
+            <a:r>
+              <a:rPr sz="1000" b="1" i="0">
+                <a:solidFill>
+                  <a:srgbClr val="25F4EE"/>
+                </a:solidFill>
+                <a:latin typeface="Arial"/>
+                <a:ea typeface="Microsoft YaHei"/>
+                <a:cs typeface="Arial"/>
+              </a:rPr>
+              <a:t>PART 1 · WHAT</a:t>
+            </a:r>
+          </a:p>
+        </p:txBody>
+      </p:sp>
+      <p:sp>
+        <p:nvSpPr>
+          <p:cNvPr id="78" name="TextBox 77"/>
+          <p:cNvSpPr txBox="1"/>
+          <p:nvPr/>
+        </p:nvSpPr>
+        <p:spPr>
+          <a:xfrm>
+            <a:off x="758952" y="3493008"/>
+            <a:ext cx="2240280" cy="640080"/>
+          </a:xfrm>
+          <a:prstGeom prst="rect">
+            <a:avLst/>
+          </a:prstGeom>
+          <a:noFill/>
+        </p:spPr>
+        <p:txBody>
+          <a:bodyPr wrap="square" lIns="0" rIns="0" tIns="0" bIns="0" anchor="t">
+            <a:spAutoFit/>
+          </a:bodyPr>
+          <a:lstStyle/>
+          <a:p>
+            <a:pPr algn="l"/>
+            <a:r>
+              <a:rPr sz="1500" b="1" i="0">
+                <a:solidFill>
+                  <a:srgbClr val="FFFFFF"/>
+                </a:solidFill>
+                <a:latin typeface="Arial"/>
+                <a:ea typeface="Microsoft YaHei"/>
+                <a:cs typeface="Arial"/>
+              </a:rPr>
+              <a:t>Background &amp; Landscape</a:t>
+            </a:r>
+          </a:p>
+        </p:txBody>
+      </p:sp>
+      <p:sp>
+        <p:nvSpPr>
+          <p:cNvPr id="79" name="TextBox 78"/>
+          <p:cNvSpPr txBox="1"/>
+          <p:nvPr/>
+        </p:nvSpPr>
+        <p:spPr>
+          <a:xfrm>
+            <a:off x="758952" y="4160520"/>
+            <a:ext cx="2240280" cy="1234440"/>
+          </a:xfrm>
+          <a:prstGeom prst="rect">
+            <a:avLst/>
+          </a:prstGeom>
+          <a:noFill/>
+        </p:spPr>
+        <p:txBody>
+          <a:bodyPr wrap="square" lIns="0" rIns="0" tIns="0" bIns="0" anchor="t">
+            <a:spAutoFit/>
+          </a:bodyPr>
+          <a:lstStyle/>
+          <a:p>
+            <a:pPr algn="l" marL="155448" indent="-155448">
+              <a:spcAft>
+                <a:spcPts val="400"/>
+              </a:spcAft>
+              <a:buClr>
+                <a:srgbClr val="25F4EE"/>
+              </a:buClr>
+              <a:buFont typeface="Arial"/>
+              <a:buChar char="•"/>
+            </a:pPr>
+            <a:r>
+              <a:rPr sz="1150" b="0" i="0">
+                <a:solidFill>
+                  <a:srgbClr val="C9C9C9"/>
+                </a:solidFill>
+                <a:latin typeface="Arial"/>
+                <a:ea typeface="Microsoft YaHei"/>
+                <a:cs typeface="Arial"/>
+              </a:rPr>
+              <a:t>Social vs. interest e-commerce</a:t>
+            </a:r>
+          </a:p>
+          <a:p>
+            <a:pPr algn="l" marL="155448" indent="-155448">
+              <a:spcAft>
+                <a:spcPts val="400"/>
+              </a:spcAft>
+              <a:buClr>
+                <a:srgbClr val="25F4EE"/>
+              </a:buClr>
+              <a:buFont typeface="Arial"/>
+              <a:buChar char="•"/>
+            </a:pPr>
+            <a:r>
+              <a:rPr sz="1150" b="0" i="0">
+                <a:solidFill>
+                  <a:srgbClr val="C9C9C9"/>
+                </a:solidFill>
+                <a:latin typeface="Arial"/>
+                <a:ea typeface="Microsoft YaHei"/>
+                <a:cs typeface="Arial"/>
+              </a:rPr>
+              <a:t>Douyin's e-commerce evolution</a:t>
+            </a:r>
+          </a:p>
+          <a:p>
+            <a:pPr algn="l" marL="155448" indent="-155448">
+              <a:spcAft>
+                <a:spcPts val="400"/>
+              </a:spcAft>
+              <a:buClr>
+                <a:srgbClr val="25F4EE"/>
+              </a:buClr>
+              <a:buFont typeface="Arial"/>
+              <a:buChar char="•"/>
+            </a:pPr>
+            <a:r>
+              <a:rPr sz="1150" b="0" i="0">
+                <a:solidFill>
+                  <a:srgbClr val="C9C9C9"/>
+                </a:solidFill>
+                <a:latin typeface="Arial"/>
+                <a:ea typeface="Microsoft YaHei"/>
+                <a:cs typeface="Arial"/>
+              </a:rPr>
+              <a:t>Current layout: content, shelf, services</a:t>
+            </a:r>
+          </a:p>
+        </p:txBody>
+      </p:sp>
+      <p:sp>
+        <p:nvSpPr>
+          <p:cNvPr id="80" name="TextBox 79"/>
+          <p:cNvSpPr txBox="1"/>
+          <p:nvPr/>
+        </p:nvSpPr>
+        <p:spPr>
+          <a:xfrm>
+            <a:off x="758952" y="5559552"/>
+            <a:ext cx="2194560" cy="274320"/>
+          </a:xfrm>
+          <a:prstGeom prst="rect">
+            <a:avLst/>
+          </a:prstGeom>
+          <a:noFill/>
+        </p:spPr>
+        <p:txBody>
+          <a:bodyPr wrap="square" lIns="0" rIns="0" tIns="0" bIns="0" anchor="t">
+            <a:spAutoFit/>
+          </a:bodyPr>
+          <a:lstStyle/>
+          <a:p>
+            <a:pPr algn="l"/>
+            <a:r>
+              <a:rPr sz="1000" b="1" i="0">
+                <a:solidFill>
+                  <a:srgbClr val="8C8C8C"/>
+                </a:solidFill>
+                <a:latin typeface="Arial"/>
+                <a:ea typeface="Microsoft YaHei"/>
+                <a:cs typeface="Arial"/>
+              </a:rPr>
+              <a:t>Time  </a:t>
+            </a:r>
+            <a:r>
+              <a:rPr sz="1200" b="1" i="0">
+                <a:solidFill>
+                  <a:srgbClr val="FFFFFF"/>
+                </a:solidFill>
+                <a:latin typeface="Arial"/>
+                <a:ea typeface="Microsoft YaHei"/>
+                <a:cs typeface="Arial"/>
+              </a:rPr>
+              <a:t>~4.5 min</a:t>
+            </a:r>
+          </a:p>
+        </p:txBody>
+      </p:sp>
+      <p:sp>
+        <p:nvSpPr>
+          <p:cNvPr id="81" name="Rounded Rectangle 80"/>
+          <p:cNvSpPr/>
+          <p:nvPr/>
+        </p:nvSpPr>
+        <p:spPr>
+          <a:xfrm>
+            <a:off x="3364991" y="1691640"/>
+            <a:ext cx="2651760" cy="4343400"/>
+          </a:xfrm>
+          <a:prstGeom prst="roundRect">
+            <a:avLst>
+              <a:gd name="adj" fmla="val 8000"/>
+            </a:avLst>
+          </a:prstGeom>
+          <a:solidFill>
+            <a:srgbClr val="0E0E0E"/>
+          </a:solidFill>
+          <a:ln w="15875">
+            <a:solidFill>
+              <a:srgbClr val="FE2C55"/>
+            </a:solidFill>
+          </a:ln>
+          <a:effectLst/>
+        </p:spPr>
+        <p:style>
+          <a:lnRef idx="1">
+            <a:schemeClr val="accent1"/>
+          </a:lnRef>
+          <a:fillRef idx="3">
+            <a:schemeClr val="accent1"/>
+          </a:fillRef>
+          <a:effectRef idx="2">
+            <a:schemeClr val="accent1"/>
+          </a:effectRef>
+          <a:fontRef idx="minor">
+            <a:schemeClr val="lt1"/>
+          </a:fontRef>
+        </p:style>
+        <p:txBody>
+          <a:bodyPr rtlCol="0" anchor="ctr"/>
+          <a:lstStyle/>
+          <a:p/>
+        </p:txBody>
+      </p:sp>
+      <p:sp>
+        <p:nvSpPr>
+          <p:cNvPr id="82" name="Oval 81"/>
+          <p:cNvSpPr/>
+          <p:nvPr/>
+        </p:nvSpPr>
+        <p:spPr>
+          <a:xfrm>
+            <a:off x="3621024" y="1965960"/>
+            <a:ext cx="685800" cy="685800"/>
+          </a:xfrm>
+          <a:prstGeom prst="ellipse">
+            <a:avLst/>
+          </a:prstGeom>
+          <a:solidFill>
+            <a:srgbClr val="FE2C55"/>
+          </a:solidFill>
+          <a:ln>
+            <a:noFill/>
+          </a:ln>
+          <a:effectLst/>
+        </p:spPr>
+        <p:style>
+          <a:lnRef idx="1">
+            <a:schemeClr val="accent1"/>
+          </a:lnRef>
+          <a:fillRef idx="3">
+            <a:schemeClr val="accent1"/>
+          </a:fillRef>
+          <a:effectRef idx="2">
+            <a:schemeClr val="accent1"/>
+          </a:effectRef>
+          <a:fontRef idx="minor">
+            <a:schemeClr val="lt1"/>
+          </a:fontRef>
+        </p:style>
+        <p:txBody>
+          <a:bodyPr rtlCol="0" anchor="ctr" lIns="0" rIns="0" tIns="0" bIns="0"/>
+          <a:lstStyle/>
+          <a:p>
+            <a:pPr algn="ctr"/>
+            <a:r>
+              <a:rPr sz="2400" b="1" i="0">
+                <a:solidFill>
+                  <a:srgbClr val="000000"/>
+                </a:solidFill>
+                <a:latin typeface="Arial"/>
+                <a:ea typeface="Microsoft YaHei"/>
+                <a:cs typeface="Arial"/>
+              </a:rPr>
+              <a:t>B</a:t>
+            </a:r>
+          </a:p>
+        </p:txBody>
+      </p:sp>
+      <p:sp>
+        <p:nvSpPr>
+          <p:cNvPr id="83" name="TextBox 82"/>
+          <p:cNvSpPr txBox="1"/>
+          <p:nvPr/>
+        </p:nvSpPr>
+        <p:spPr>
+          <a:xfrm>
+            <a:off x="3621024" y="2834640"/>
+            <a:ext cx="2194560" cy="320040"/>
+          </a:xfrm>
+          <a:prstGeom prst="rect">
+            <a:avLst/>
+          </a:prstGeom>
+          <a:noFill/>
+        </p:spPr>
+        <p:txBody>
+          <a:bodyPr wrap="square" lIns="0" rIns="0" tIns="0" bIns="0" anchor="t">
+            <a:spAutoFit/>
+          </a:bodyPr>
+          <a:lstStyle/>
+          <a:p>
+            <a:pPr algn="l"/>
+            <a:r>
+              <a:rPr sz="1500" b="1" i="0">
+                <a:solidFill>
+                  <a:srgbClr val="FFFFFF"/>
+                </a:solidFill>
+                <a:latin typeface="Arial"/>
+                <a:ea typeface="Microsoft YaHei"/>
+                <a:cs typeface="Arial"/>
+              </a:rPr>
+              <a:t>[Member B]</a:t>
+            </a:r>
+          </a:p>
+        </p:txBody>
+      </p:sp>
+      <p:sp>
+        <p:nvSpPr>
+          <p:cNvPr id="84" name="TextBox 83"/>
+          <p:cNvSpPr txBox="1"/>
+          <p:nvPr/>
+        </p:nvSpPr>
+        <p:spPr>
+          <a:xfrm>
+            <a:off x="3621024" y="3200400"/>
+            <a:ext cx="2194560" cy="274320"/>
+          </a:xfrm>
+          <a:prstGeom prst="rect">
+            <a:avLst/>
+          </a:prstGeom>
+          <a:noFill/>
+        </p:spPr>
+        <p:txBody>
+          <a:bodyPr wrap="square" lIns="0" rIns="0" tIns="0" bIns="0" anchor="t">
+            <a:spAutoFit/>
+          </a:bodyPr>
+          <a:lstStyle/>
+          <a:p>
+            <a:pPr algn="l"/>
+            <a:r>
+              <a:rPr sz="1000" b="1" i="0">
+                <a:solidFill>
+                  <a:srgbClr val="FE2C55"/>
+                </a:solidFill>
+                <a:latin typeface="Arial"/>
+                <a:ea typeface="Microsoft YaHei"/>
+                <a:cs typeface="Arial"/>
+              </a:rPr>
+              <a:t>PART 2 · WHY</a:t>
+            </a:r>
+          </a:p>
+        </p:txBody>
+      </p:sp>
+      <p:sp>
+        <p:nvSpPr>
+          <p:cNvPr id="85" name="TextBox 84"/>
+          <p:cNvSpPr txBox="1"/>
+          <p:nvPr/>
+        </p:nvSpPr>
+        <p:spPr>
+          <a:xfrm>
+            <a:off x="3621024" y="3493008"/>
+            <a:ext cx="2240280" cy="640080"/>
+          </a:xfrm>
+          <a:prstGeom prst="rect">
+            <a:avLst/>
+          </a:prstGeom>
+          <a:noFill/>
+        </p:spPr>
+        <p:txBody>
+          <a:bodyPr wrap="square" lIns="0" rIns="0" tIns="0" bIns="0" anchor="t">
+            <a:spAutoFit/>
+          </a:bodyPr>
+          <a:lstStyle/>
+          <a:p>
+            <a:pPr algn="l"/>
+            <a:r>
+              <a:rPr sz="1500" b="1" i="0">
+                <a:solidFill>
+                  <a:srgbClr val="FFFFFF"/>
+                </a:solidFill>
+                <a:latin typeface="Arial"/>
+                <a:ea typeface="Microsoft YaHei"/>
+                <a:cs typeface="Arial"/>
+              </a:rPr>
+              <a:t>Drivers of Entry</a:t>
+            </a:r>
+          </a:p>
+        </p:txBody>
+      </p:sp>
+      <p:sp>
+        <p:nvSpPr>
+          <p:cNvPr id="86" name="TextBox 85"/>
+          <p:cNvSpPr txBox="1"/>
+          <p:nvPr/>
+        </p:nvSpPr>
+        <p:spPr>
+          <a:xfrm>
+            <a:off x="3621024" y="4160520"/>
+            <a:ext cx="2240280" cy="1234440"/>
+          </a:xfrm>
+          <a:prstGeom prst="rect">
+            <a:avLst/>
+          </a:prstGeom>
+          <a:noFill/>
+        </p:spPr>
+        <p:txBody>
+          <a:bodyPr wrap="square" lIns="0" rIns="0" tIns="0" bIns="0" anchor="t">
+            <a:spAutoFit/>
+          </a:bodyPr>
+          <a:lstStyle/>
+          <a:p>
+            <a:pPr algn="l" marL="155448" indent="-155448">
+              <a:spcAft>
+                <a:spcPts val="400"/>
+              </a:spcAft>
+              <a:buClr>
+                <a:srgbClr val="FE2C55"/>
+              </a:buClr>
+              <a:buFont typeface="Arial"/>
+              <a:buChar char="•"/>
+            </a:pPr>
+            <a:r>
+              <a:rPr sz="1150" b="0" i="0">
+                <a:solidFill>
+                  <a:srgbClr val="C9C9C9"/>
+                </a:solidFill>
+                <a:latin typeface="Arial"/>
+                <a:ea typeface="Microsoft YaHei"/>
+                <a:cs typeface="Arial"/>
+              </a:rPr>
+              <a:t>Users, traffic and content power</a:t>
+            </a:r>
+          </a:p>
+          <a:p>
+            <a:pPr algn="l" marL="155448" indent="-155448">
+              <a:spcAft>
+                <a:spcPts val="400"/>
+              </a:spcAft>
+              <a:buClr>
+                <a:srgbClr val="FE2C55"/>
+              </a:buClr>
+              <a:buFont typeface="Arial"/>
+              <a:buChar char="•"/>
+            </a:pPr>
+            <a:r>
+              <a:rPr sz="1150" b="0" i="0">
+                <a:solidFill>
+                  <a:srgbClr val="C9C9C9"/>
+                </a:solidFill>
+                <a:latin typeface="Arial"/>
+                <a:ea typeface="Microsoft YaHei"/>
+                <a:cs typeface="Arial"/>
+              </a:rPr>
+              <a:t>Algorithms and data</a:t>
+            </a:r>
+          </a:p>
+          <a:p>
+            <a:pPr algn="l" marL="155448" indent="-155448">
+              <a:spcAft>
+                <a:spcPts val="400"/>
+              </a:spcAft>
+              <a:buClr>
+                <a:srgbClr val="FE2C55"/>
+              </a:buClr>
+              <a:buFont typeface="Arial"/>
+              <a:buChar char="•"/>
+            </a:pPr>
+            <a:r>
+              <a:rPr sz="1150" b="0" i="0">
+                <a:solidFill>
+                  <a:srgbClr val="C9C9C9"/>
+                </a:solidFill>
+                <a:latin typeface="Arial"/>
+                <a:ea typeface="Microsoft YaHei"/>
+                <a:cs typeface="Arial"/>
+              </a:rPr>
+              <a:t>Monetisation and competition</a:t>
+            </a:r>
+          </a:p>
+        </p:txBody>
+      </p:sp>
+      <p:sp>
+        <p:nvSpPr>
+          <p:cNvPr id="87" name="TextBox 86"/>
+          <p:cNvSpPr txBox="1"/>
+          <p:nvPr/>
+        </p:nvSpPr>
+        <p:spPr>
+          <a:xfrm>
+            <a:off x="3621024" y="5559552"/>
+            <a:ext cx="2194560" cy="274320"/>
+          </a:xfrm>
+          <a:prstGeom prst="rect">
+            <a:avLst/>
+          </a:prstGeom>
+          <a:noFill/>
+        </p:spPr>
+        <p:txBody>
+          <a:bodyPr wrap="square" lIns="0" rIns="0" tIns="0" bIns="0" anchor="t">
+            <a:spAutoFit/>
+          </a:bodyPr>
+          <a:lstStyle/>
+          <a:p>
+            <a:pPr algn="l"/>
+            <a:r>
+              <a:rPr sz="1000" b="1" i="0">
+                <a:solidFill>
+                  <a:srgbClr val="8C8C8C"/>
+                </a:solidFill>
+                <a:latin typeface="Arial"/>
+                <a:ea typeface="Microsoft YaHei"/>
+                <a:cs typeface="Arial"/>
+              </a:rPr>
+              <a:t>Time  </a:t>
+            </a:r>
+            <a:r>
+              <a:rPr sz="1200" b="1" i="0">
+                <a:solidFill>
+                  <a:srgbClr val="FFFFFF"/>
+                </a:solidFill>
+                <a:latin typeface="Arial"/>
+                <a:ea typeface="Microsoft YaHei"/>
+                <a:cs typeface="Arial"/>
+              </a:rPr>
+              <a:t>~4 min</a:t>
+            </a:r>
+          </a:p>
+        </p:txBody>
+      </p:sp>
+      <p:sp>
+        <p:nvSpPr>
+          <p:cNvPr id="88" name="Rounded Rectangle 87"/>
+          <p:cNvSpPr/>
+          <p:nvPr/>
+        </p:nvSpPr>
+        <p:spPr>
+          <a:xfrm>
+            <a:off x="6227064" y="1691640"/>
+            <a:ext cx="2651760" cy="4343400"/>
+          </a:xfrm>
+          <a:prstGeom prst="roundRect">
+            <a:avLst>
+              <a:gd name="adj" fmla="val 8000"/>
+            </a:avLst>
+          </a:prstGeom>
+          <a:solidFill>
+            <a:srgbClr val="0E0E0E"/>
+          </a:solidFill>
+          <a:ln w="15875">
+            <a:solidFill>
+              <a:srgbClr val="25F4EE"/>
+            </a:solidFill>
+          </a:ln>
+          <a:effectLst/>
+        </p:spPr>
+        <p:style>
+          <a:lnRef idx="1">
+            <a:schemeClr val="accent1"/>
+          </a:lnRef>
+          <a:fillRef idx="3">
+            <a:schemeClr val="accent1"/>
+          </a:fillRef>
+          <a:effectRef idx="2">
+            <a:schemeClr val="accent1"/>
+          </a:effectRef>
+          <a:fontRef idx="minor">
+            <a:schemeClr val="lt1"/>
+          </a:fontRef>
+        </p:style>
+        <p:txBody>
+          <a:bodyPr rtlCol="0" anchor="ctr"/>
+          <a:lstStyle/>
+          <a:p/>
+        </p:txBody>
+      </p:sp>
+      <p:sp>
+        <p:nvSpPr>
+          <p:cNvPr id="89" name="Oval 88"/>
+          <p:cNvSpPr/>
+          <p:nvPr/>
+        </p:nvSpPr>
+        <p:spPr>
+          <a:xfrm>
+            <a:off x="6483096" y="1965960"/>
+            <a:ext cx="685800" cy="685800"/>
+          </a:xfrm>
+          <a:prstGeom prst="ellipse">
+            <a:avLst/>
+          </a:prstGeom>
+          <a:solidFill>
+            <a:srgbClr val="25F4EE"/>
+          </a:solidFill>
+          <a:ln>
+            <a:noFill/>
+          </a:ln>
+          <a:effectLst/>
+        </p:spPr>
+        <p:style>
+          <a:lnRef idx="1">
+            <a:schemeClr val="accent1"/>
+          </a:lnRef>
+          <a:fillRef idx="3">
+            <a:schemeClr val="accent1"/>
+          </a:fillRef>
+          <a:effectRef idx="2">
+            <a:schemeClr val="accent1"/>
+          </a:effectRef>
+          <a:fontRef idx="minor">
+            <a:schemeClr val="lt1"/>
+          </a:fontRef>
+        </p:style>
+        <p:txBody>
+          <a:bodyPr rtlCol="0" anchor="ctr" lIns="0" rIns="0" tIns="0" bIns="0"/>
+          <a:lstStyle/>
+          <a:p>
+            <a:pPr algn="ctr"/>
+            <a:r>
+              <a:rPr sz="2400" b="1" i="0">
+                <a:solidFill>
+                  <a:srgbClr val="000000"/>
+                </a:solidFill>
+                <a:latin typeface="Arial"/>
+                <a:ea typeface="Microsoft YaHei"/>
+                <a:cs typeface="Arial"/>
+              </a:rPr>
+              <a:t>C</a:t>
+            </a:r>
+          </a:p>
+        </p:txBody>
+      </p:sp>
+      <p:sp>
+        <p:nvSpPr>
+          <p:cNvPr id="90" name="TextBox 89"/>
+          <p:cNvSpPr txBox="1"/>
+          <p:nvPr/>
+        </p:nvSpPr>
+        <p:spPr>
+          <a:xfrm>
+            <a:off x="6483096" y="2834640"/>
+            <a:ext cx="2194560" cy="320040"/>
+          </a:xfrm>
+          <a:prstGeom prst="rect">
+            <a:avLst/>
+          </a:prstGeom>
+          <a:noFill/>
+        </p:spPr>
+        <p:txBody>
+          <a:bodyPr wrap="square" lIns="0" rIns="0" tIns="0" bIns="0" anchor="t">
+            <a:spAutoFit/>
+          </a:bodyPr>
+          <a:lstStyle/>
+          <a:p>
+            <a:pPr algn="l"/>
+            <a:r>
+              <a:rPr sz="1500" b="1" i="0">
+                <a:solidFill>
+                  <a:srgbClr val="FFFFFF"/>
+                </a:solidFill>
+                <a:latin typeface="Arial"/>
+                <a:ea typeface="Microsoft YaHei"/>
+                <a:cs typeface="Arial"/>
+              </a:rPr>
+              <a:t>[Member C]</a:t>
+            </a:r>
+          </a:p>
+        </p:txBody>
+      </p:sp>
+      <p:sp>
+        <p:nvSpPr>
+          <p:cNvPr id="91" name="TextBox 90"/>
+          <p:cNvSpPr txBox="1"/>
+          <p:nvPr/>
+        </p:nvSpPr>
+        <p:spPr>
+          <a:xfrm>
+            <a:off x="6483096" y="3200400"/>
+            <a:ext cx="2194560" cy="274320"/>
+          </a:xfrm>
+          <a:prstGeom prst="rect">
+            <a:avLst/>
+          </a:prstGeom>
+          <a:noFill/>
+        </p:spPr>
+        <p:txBody>
+          <a:bodyPr wrap="square" lIns="0" rIns="0" tIns="0" bIns="0" anchor="t">
+            <a:spAutoFit/>
+          </a:bodyPr>
+          <a:lstStyle/>
+          <a:p>
+            <a:pPr algn="l"/>
+            <a:r>
+              <a:rPr sz="1000" b="1" i="0">
+                <a:solidFill>
+                  <a:srgbClr val="25F4EE"/>
+                </a:solidFill>
+                <a:latin typeface="Arial"/>
+                <a:ea typeface="Microsoft YaHei"/>
+                <a:cs typeface="Arial"/>
+              </a:rPr>
+              <a:t>PART 3 · HOW</a:t>
+            </a:r>
+          </a:p>
+        </p:txBody>
+      </p:sp>
+      <p:sp>
+        <p:nvSpPr>
+          <p:cNvPr id="92" name="TextBox 91"/>
+          <p:cNvSpPr txBox="1"/>
+          <p:nvPr/>
+        </p:nvSpPr>
+        <p:spPr>
+          <a:xfrm>
+            <a:off x="6483096" y="3493008"/>
+            <a:ext cx="2240280" cy="640080"/>
+          </a:xfrm>
+          <a:prstGeom prst="rect">
+            <a:avLst/>
+          </a:prstGeom>
+          <a:noFill/>
+        </p:spPr>
+        <p:txBody>
+          <a:bodyPr wrap="square" lIns="0" rIns="0" tIns="0" bIns="0" anchor="t">
+            <a:spAutoFit/>
+          </a:bodyPr>
+          <a:lstStyle/>
+          <a:p>
+            <a:pPr algn="l"/>
+            <a:r>
+              <a:rPr sz="1500" b="1" i="0">
+                <a:solidFill>
+                  <a:srgbClr val="FFFFFF"/>
+                </a:solidFill>
+                <a:latin typeface="Arial"/>
+                <a:ea typeface="Microsoft YaHei"/>
+                <a:cs typeface="Arial"/>
+              </a:rPr>
+              <a:t>Business Model &amp; Marketing</a:t>
+            </a:r>
+          </a:p>
+        </p:txBody>
+      </p:sp>
+      <p:sp>
+        <p:nvSpPr>
+          <p:cNvPr id="93" name="TextBox 92"/>
+          <p:cNvSpPr txBox="1"/>
+          <p:nvPr/>
+        </p:nvSpPr>
+        <p:spPr>
+          <a:xfrm>
+            <a:off x="6483096" y="4160520"/>
+            <a:ext cx="2240280" cy="1234440"/>
+          </a:xfrm>
+          <a:prstGeom prst="rect">
+            <a:avLst/>
+          </a:prstGeom>
+          <a:noFill/>
+        </p:spPr>
+        <p:txBody>
+          <a:bodyPr wrap="square" lIns="0" rIns="0" tIns="0" bIns="0" anchor="t">
+            <a:spAutoFit/>
+          </a:bodyPr>
+          <a:lstStyle/>
+          <a:p>
+            <a:pPr algn="l" marL="155448" indent="-155448">
+              <a:spcAft>
+                <a:spcPts val="400"/>
+              </a:spcAft>
+              <a:buClr>
+                <a:srgbClr val="25F4EE"/>
+              </a:buClr>
+              <a:buFont typeface="Arial"/>
+              <a:buChar char="•"/>
+            </a:pPr>
+            <a:r>
+              <a:rPr sz="1150" b="0" i="0">
+                <a:solidFill>
+                  <a:srgbClr val="C9C9C9"/>
+                </a:solidFill>
+                <a:latin typeface="Arial"/>
+                <a:ea typeface="Microsoft YaHei"/>
+                <a:cs typeface="Arial"/>
+              </a:rPr>
+              <a:t>Interest e-commerce logic</a:t>
+            </a:r>
+          </a:p>
+          <a:p>
+            <a:pPr algn="l" marL="155448" indent="-155448">
+              <a:spcAft>
+                <a:spcPts val="400"/>
+              </a:spcAft>
+              <a:buClr>
+                <a:srgbClr val="25F4EE"/>
+              </a:buClr>
+              <a:buFont typeface="Arial"/>
+              <a:buChar char="•"/>
+            </a:pPr>
+            <a:r>
+              <a:rPr sz="1150" b="0" i="0">
+                <a:solidFill>
+                  <a:srgbClr val="C9C9C9"/>
+                </a:solidFill>
+                <a:latin typeface="Arial"/>
+                <a:ea typeface="Microsoft YaHei"/>
+                <a:cs typeface="Arial"/>
+              </a:rPr>
+              <a:t>Scenes, players and revenue</a:t>
+            </a:r>
+          </a:p>
+          <a:p>
+            <a:pPr algn="l" marL="155448" indent="-155448">
+              <a:spcAft>
+                <a:spcPts val="400"/>
+              </a:spcAft>
+              <a:buClr>
+                <a:srgbClr val="25F4EE"/>
+              </a:buClr>
+              <a:buFont typeface="Arial"/>
+              <a:buChar char="•"/>
+            </a:pPr>
+            <a:r>
+              <a:rPr sz="1150" b="0" i="0">
+                <a:solidFill>
+                  <a:srgbClr val="C9C9C9"/>
+                </a:solidFill>
+                <a:latin typeface="Arial"/>
+                <a:ea typeface="Microsoft YaHei"/>
+                <a:cs typeface="Arial"/>
+              </a:rPr>
+              <a:t>New-media marketing funnel</a:t>
+            </a:r>
+          </a:p>
+        </p:txBody>
+      </p:sp>
+      <p:sp>
+        <p:nvSpPr>
+          <p:cNvPr id="94" name="TextBox 93"/>
+          <p:cNvSpPr txBox="1"/>
+          <p:nvPr/>
+        </p:nvSpPr>
+        <p:spPr>
+          <a:xfrm>
+            <a:off x="6483096" y="5559552"/>
+            <a:ext cx="2194560" cy="274320"/>
+          </a:xfrm>
+          <a:prstGeom prst="rect">
+            <a:avLst/>
+          </a:prstGeom>
+          <a:noFill/>
+        </p:spPr>
+        <p:txBody>
+          <a:bodyPr wrap="square" lIns="0" rIns="0" tIns="0" bIns="0" anchor="t">
+            <a:spAutoFit/>
+          </a:bodyPr>
+          <a:lstStyle/>
+          <a:p>
+            <a:pPr algn="l"/>
+            <a:r>
+              <a:rPr sz="1000" b="1" i="0">
+                <a:solidFill>
+                  <a:srgbClr val="8C8C8C"/>
+                </a:solidFill>
+                <a:latin typeface="Arial"/>
+                <a:ea typeface="Microsoft YaHei"/>
+                <a:cs typeface="Arial"/>
+              </a:rPr>
+              <a:t>Time  </a:t>
+            </a:r>
+            <a:r>
+              <a:rPr sz="1200" b="1" i="0">
+                <a:solidFill>
+                  <a:srgbClr val="FFFFFF"/>
+                </a:solidFill>
+                <a:latin typeface="Arial"/>
+                <a:ea typeface="Microsoft YaHei"/>
+                <a:cs typeface="Arial"/>
+              </a:rPr>
+              <a:t>4–5 min</a:t>
+            </a:r>
+          </a:p>
+        </p:txBody>
+      </p:sp>
+      <p:sp>
+        <p:nvSpPr>
+          <p:cNvPr id="95" name="Rounded Rectangle 94"/>
+          <p:cNvSpPr/>
+          <p:nvPr/>
+        </p:nvSpPr>
+        <p:spPr>
+          <a:xfrm>
+            <a:off x="9089136" y="1691640"/>
+            <a:ext cx="2651760" cy="4343400"/>
+          </a:xfrm>
+          <a:prstGeom prst="roundRect">
+            <a:avLst>
+              <a:gd name="adj" fmla="val 8000"/>
+            </a:avLst>
+          </a:prstGeom>
+          <a:solidFill>
+            <a:srgbClr val="0E0E0E"/>
+          </a:solidFill>
+          <a:ln w="15875">
+            <a:solidFill>
+              <a:srgbClr val="FE2C55"/>
+            </a:solidFill>
+          </a:ln>
+          <a:effectLst/>
+        </p:spPr>
+        <p:style>
+          <a:lnRef idx="1">
+            <a:schemeClr val="accent1"/>
+          </a:lnRef>
+          <a:fillRef idx="3">
+            <a:schemeClr val="accent1"/>
+          </a:fillRef>
+          <a:effectRef idx="2">
+            <a:schemeClr val="accent1"/>
+          </a:effectRef>
+          <a:fontRef idx="minor">
+            <a:schemeClr val="lt1"/>
+          </a:fontRef>
+        </p:style>
+        <p:txBody>
+          <a:bodyPr rtlCol="0" anchor="ctr"/>
+          <a:lstStyle/>
+          <a:p/>
+        </p:txBody>
+      </p:sp>
+      <p:sp>
+        <p:nvSpPr>
+          <p:cNvPr id="96" name="Oval 95"/>
+          <p:cNvSpPr/>
+          <p:nvPr/>
+        </p:nvSpPr>
+        <p:spPr>
+          <a:xfrm>
+            <a:off x="9345168" y="1965960"/>
+            <a:ext cx="685800" cy="685800"/>
+          </a:xfrm>
+          <a:prstGeom prst="ellipse">
+            <a:avLst/>
+          </a:prstGeom>
+          <a:solidFill>
+            <a:srgbClr val="FE2C55"/>
+          </a:solidFill>
+          <a:ln>
+            <a:noFill/>
+          </a:ln>
+          <a:effectLst/>
+        </p:spPr>
+        <p:style>
+          <a:lnRef idx="1">
+            <a:schemeClr val="accent1"/>
+          </a:lnRef>
+          <a:fillRef idx="3">
+            <a:schemeClr val="accent1"/>
+          </a:fillRef>
+          <a:effectRef idx="2">
+            <a:schemeClr val="accent1"/>
+          </a:effectRef>
+          <a:fontRef idx="minor">
+            <a:schemeClr val="lt1"/>
+          </a:fontRef>
+        </p:style>
+        <p:txBody>
+          <a:bodyPr rtlCol="0" anchor="ctr" lIns="0" rIns="0" tIns="0" bIns="0"/>
+          <a:lstStyle/>
+          <a:p>
+            <a:pPr algn="ctr"/>
+            <a:r>
+              <a:rPr sz="2400" b="1" i="0">
+                <a:solidFill>
+                  <a:srgbClr val="000000"/>
+                </a:solidFill>
+                <a:latin typeface="Arial"/>
+                <a:ea typeface="Microsoft YaHei"/>
+                <a:cs typeface="Arial"/>
+              </a:rPr>
+              <a:t>D</a:t>
+            </a:r>
+          </a:p>
+        </p:txBody>
+      </p:sp>
+      <p:sp>
+        <p:nvSpPr>
+          <p:cNvPr id="97" name="TextBox 96"/>
+          <p:cNvSpPr txBox="1"/>
+          <p:nvPr/>
+        </p:nvSpPr>
+        <p:spPr>
+          <a:xfrm>
+            <a:off x="9345168" y="2834640"/>
+            <a:ext cx="2194560" cy="320040"/>
+          </a:xfrm>
+          <a:prstGeom prst="rect">
+            <a:avLst/>
+          </a:prstGeom>
+          <a:noFill/>
+        </p:spPr>
+        <p:txBody>
+          <a:bodyPr wrap="square" lIns="0" rIns="0" tIns="0" bIns="0" anchor="t">
+            <a:spAutoFit/>
+          </a:bodyPr>
+          <a:lstStyle/>
+          <a:p>
+            <a:pPr algn="l"/>
+            <a:r>
+              <a:rPr sz="1500" b="1" i="0">
+                <a:solidFill>
+                  <a:srgbClr val="FFFFFF"/>
+                </a:solidFill>
+                <a:latin typeface="Arial"/>
+                <a:ea typeface="Microsoft YaHei"/>
+                <a:cs typeface="Arial"/>
+              </a:rPr>
+              <a:t>[Member D]</a:t>
+            </a:r>
+          </a:p>
+        </p:txBody>
+      </p:sp>
+      <p:sp>
+        <p:nvSpPr>
+          <p:cNvPr id="98" name="TextBox 97"/>
+          <p:cNvSpPr txBox="1"/>
+          <p:nvPr/>
+        </p:nvSpPr>
+        <p:spPr>
+          <a:xfrm>
+            <a:off x="9345168" y="3200400"/>
+            <a:ext cx="2194560" cy="274320"/>
+          </a:xfrm>
+          <a:prstGeom prst="rect">
+            <a:avLst/>
+          </a:prstGeom>
+          <a:noFill/>
+        </p:spPr>
+        <p:txBody>
+          <a:bodyPr wrap="square" lIns="0" rIns="0" tIns="0" bIns="0" anchor="t">
+            <a:spAutoFit/>
+          </a:bodyPr>
+          <a:lstStyle/>
+          <a:p>
+            <a:pPr algn="l"/>
+            <a:r>
+              <a:rPr sz="1000" b="1" i="0">
+                <a:solidFill>
+                  <a:srgbClr val="FE2C55"/>
+                </a:solidFill>
+                <a:latin typeface="Arial"/>
+                <a:ea typeface="Microsoft YaHei"/>
+                <a:cs typeface="Arial"/>
+              </a:rPr>
+              <a:t>PART 4 · WHERE NEXT</a:t>
+            </a:r>
+          </a:p>
+        </p:txBody>
+      </p:sp>
+      <p:sp>
+        <p:nvSpPr>
+          <p:cNvPr id="99" name="TextBox 98"/>
+          <p:cNvSpPr txBox="1"/>
+          <p:nvPr/>
+        </p:nvSpPr>
+        <p:spPr>
+          <a:xfrm>
+            <a:off x="9345168" y="3493008"/>
+            <a:ext cx="2240280" cy="640080"/>
+          </a:xfrm>
+          <a:prstGeom prst="rect">
+            <a:avLst/>
+          </a:prstGeom>
+          <a:noFill/>
+        </p:spPr>
+        <p:txBody>
+          <a:bodyPr wrap="square" lIns="0" rIns="0" tIns="0" bIns="0" anchor="t">
+            <a:spAutoFit/>
+          </a:bodyPr>
+          <a:lstStyle/>
+          <a:p>
+            <a:pPr algn="l"/>
+            <a:r>
+              <a:rPr sz="1500" b="1" i="0">
+                <a:solidFill>
+                  <a:srgbClr val="FFFFFF"/>
+                </a:solidFill>
+                <a:latin typeface="Arial"/>
+                <a:ea typeface="Microsoft YaHei"/>
+                <a:cs typeface="Arial"/>
+              </a:rPr>
+              <a:t>Risks, Prospects &amp; Conclusion</a:t>
+            </a:r>
+          </a:p>
+        </p:txBody>
+      </p:sp>
+      <p:sp>
+        <p:nvSpPr>
+          <p:cNvPr id="100" name="TextBox 99"/>
+          <p:cNvSpPr txBox="1"/>
+          <p:nvPr/>
+        </p:nvSpPr>
+        <p:spPr>
+          <a:xfrm>
+            <a:off x="9345168" y="4160520"/>
+            <a:ext cx="2240280" cy="1234440"/>
+          </a:xfrm>
+          <a:prstGeom prst="rect">
+            <a:avLst/>
+          </a:prstGeom>
+          <a:noFill/>
+        </p:spPr>
+        <p:txBody>
+          <a:bodyPr wrap="square" lIns="0" rIns="0" tIns="0" bIns="0" anchor="t">
+            <a:spAutoFit/>
+          </a:bodyPr>
+          <a:lstStyle/>
+          <a:p>
+            <a:pPr algn="l" marL="155448" indent="-155448">
+              <a:spcAft>
+                <a:spcPts val="400"/>
+              </a:spcAft>
+              <a:buClr>
+                <a:srgbClr val="FE2C55"/>
+              </a:buClr>
+              <a:buFont typeface="Arial"/>
+              <a:buChar char="•"/>
+            </a:pPr>
+            <a:r>
+              <a:rPr sz="1150" b="0" i="0">
+                <a:solidFill>
+                  <a:srgbClr val="C9C9C9"/>
+                </a:solidFill>
+                <a:latin typeface="Arial"/>
+                <a:ea typeface="Microsoft YaHei"/>
+                <a:cs typeface="Arial"/>
+              </a:rPr>
+              <a:t>Current problems and risks</a:t>
+            </a:r>
+          </a:p>
+          <a:p>
+            <a:pPr algn="l" marL="155448" indent="-155448">
+              <a:spcAft>
+                <a:spcPts val="400"/>
+              </a:spcAft>
+              <a:buClr>
+                <a:srgbClr val="FE2C55"/>
+              </a:buClr>
+              <a:buFont typeface="Arial"/>
+              <a:buChar char="•"/>
+            </a:pPr>
+            <a:r>
+              <a:rPr sz="1150" b="0" i="0">
+                <a:solidFill>
+                  <a:srgbClr val="C9C9C9"/>
+                </a:solidFill>
+                <a:latin typeface="Arial"/>
+                <a:ea typeface="Microsoft YaHei"/>
+                <a:cs typeface="Arial"/>
+              </a:rPr>
+              <a:t>Future trends</a:t>
+            </a:r>
+          </a:p>
+          <a:p>
+            <a:pPr algn="l" marL="155448" indent="-155448">
+              <a:spcAft>
+                <a:spcPts val="400"/>
+              </a:spcAft>
+              <a:buClr>
+                <a:srgbClr val="FE2C55"/>
+              </a:buClr>
+              <a:buFont typeface="Arial"/>
+              <a:buChar char="•"/>
+            </a:pPr>
+            <a:r>
+              <a:rPr sz="1150" b="0" i="0">
+                <a:solidFill>
+                  <a:srgbClr val="C9C9C9"/>
+                </a:solidFill>
+                <a:latin typeface="Arial"/>
+                <a:ea typeface="Microsoft YaHei"/>
+                <a:cs typeface="Arial"/>
+              </a:rPr>
+              <a:t>Recommendations and conclusion</a:t>
+            </a:r>
+          </a:p>
+        </p:txBody>
+      </p:sp>
+      <p:sp>
+        <p:nvSpPr>
+          <p:cNvPr id="101" name="TextBox 100"/>
+          <p:cNvSpPr txBox="1"/>
+          <p:nvPr/>
+        </p:nvSpPr>
+        <p:spPr>
+          <a:xfrm>
+            <a:off x="9345168" y="5559552"/>
+            <a:ext cx="2194560" cy="274320"/>
+          </a:xfrm>
+          <a:prstGeom prst="rect">
+            <a:avLst/>
+          </a:prstGeom>
+          <a:noFill/>
+        </p:spPr>
+        <p:txBody>
+          <a:bodyPr wrap="square" lIns="0" rIns="0" tIns="0" bIns="0" anchor="t">
+            <a:spAutoFit/>
+          </a:bodyPr>
+          <a:lstStyle/>
+          <a:p>
+            <a:pPr algn="l"/>
+            <a:r>
+              <a:rPr sz="1000" b="1" i="0">
+                <a:solidFill>
+                  <a:srgbClr val="8C8C8C"/>
+                </a:solidFill>
+                <a:latin typeface="Arial"/>
+                <a:ea typeface="Microsoft YaHei"/>
+                <a:cs typeface="Arial"/>
+              </a:rPr>
+              <a:t>Time  </a:t>
+            </a:r>
+            <a:r>
+              <a:rPr sz="1200" b="1" i="0">
+                <a:solidFill>
+                  <a:srgbClr val="FFFFFF"/>
+                </a:solidFill>
+                <a:latin typeface="Arial"/>
+                <a:ea typeface="Microsoft YaHei"/>
+                <a:cs typeface="Arial"/>
+              </a:rPr>
+              <a:t>4–5 min</a:t>
+            </a:r>
+          </a:p>
+        </p:txBody>
+      </p:sp>
+    </p:spTree>
+  </p:cSld>
+  <p:clrMapOvr>
+    <a:masterClrMapping/>
+  </p:clrMapOvr>
+</p:sld>
+</file>
+
+<file path=ppt/slides/slide3.xml><?xml version="1.0" encoding="utf-8"?>
+<p:sld xmlns:a="http://schemas.openxmlformats.org/drawingml/2006/main" xmlns:r="http://schemas.openxmlformats.org/officeDocument/2006/relationships" xmlns:p="http://schemas.openxmlformats.org/presentationml/2006/main">
+  <p:cSld>
+    <p:bg>
+      <p:bgPr>
+        <a:solidFill>
+          <a:schemeClr val="tx1"/>
+        </a:solidFill>
+        <a:effectLst/>
+      </p:bgPr>
+    </p:bg>
+    <p:spTree>
+      <p:nvGrpSpPr>
+        <p:cNvPr id="1" name=""/>
+        <p:cNvGrpSpPr/>
+        <p:nvPr/>
+      </p:nvGrpSpPr>
+      <p:grpSpPr>
+        <a:xfrm>
+          <a:off x="0" y="0"/>
+          <a:ext cx="0" cy="0"/>
+          <a:chOff x="0" y="0"/>
+          <a:chExt cx="0" cy="0"/>
+        </a:xfrm>
+      </p:grpSpPr>
       <p:grpSp>
         <p:nvGrpSpPr>
           <p:cNvPr id="15" name="object 15"/>
@@ -3059,7 +4721,7 @@
 </p:sld>
 </file>
 
-<file path=ppt/slides/slide3.xml><?xml version="1.0" encoding="utf-8"?>
+<file path=ppt/slides/slide4.xml><?xml version="1.0" encoding="utf-8"?>
 <p:sld xmlns:a="http://schemas.openxmlformats.org/drawingml/2006/main" xmlns:r="http://schemas.openxmlformats.org/officeDocument/2006/relationships" xmlns:p="http://schemas.openxmlformats.org/presentationml/2006/main">
   <p:cSld>
     <p:bg>
@@ -4276,7 +5938,7 @@
 </p:sld>
 </file>
 
-<file path=ppt/slides/slide4.xml><?xml version="1.0" encoding="utf-8"?>
+<file path=ppt/slides/slide5.xml><?xml version="1.0" encoding="utf-8"?>
 <p:sld xmlns:a="http://schemas.openxmlformats.org/drawingml/2006/main" xmlns:r="http://schemas.openxmlformats.org/officeDocument/2006/relationships" xmlns:p="http://schemas.openxmlformats.org/presentationml/2006/main">
   <p:cSld>
     <p:bg>
@@ -8101,7 +9763,7 @@
 </p:sld>
 </file>
 
-<file path=ppt/slides/slide5.xml><?xml version="1.0" encoding="utf-8"?>
+<file path=ppt/slides/slide6.xml><?xml version="1.0" encoding="utf-8"?>
 <p:sld xmlns:a="http://schemas.openxmlformats.org/drawingml/2006/main" xmlns:r="http://schemas.openxmlformats.org/officeDocument/2006/relationships" xmlns:p="http://schemas.openxmlformats.org/presentationml/2006/main">
   <p:cSld>
     <p:bg>
@@ -8820,7 +10482,7 @@
 </p:sld>
 </file>
 
-<file path=ppt/slides/slide6.xml><?xml version="1.0" encoding="utf-8"?>
+<file path=ppt/slides/slide7.xml><?xml version="1.0" encoding="utf-8"?>
 <p:sld xmlns:a="http://schemas.openxmlformats.org/drawingml/2006/main" xmlns:r="http://schemas.openxmlformats.org/officeDocument/2006/relationships" xmlns:p="http://schemas.openxmlformats.org/presentationml/2006/main">
   <p:cSld>
     <p:bg>

</xml_diff>